<commit_message>
Add 26S1 Group 5 authors to report and presentation
</commit_message>
<xml_diff>
--- a/Revisiting_Lifetime_Aware_VM_Allocation_Presentation_v3.pptx
+++ b/Revisiting_Lifetime_Aware_VM_Allocation_Presentation_v3.pptx
@@ -321,7 +321,7 @@
                   <c:v>-0.1406</c:v>
                 </c:pt>
                 <c:pt idx="1">
-                  <c:v>0.0821</c:v>
+                  <c:v>0.08210000000000001</c:v>
                 </c:pt>
                 <c:pt idx="2">
                   <c:v>0.2746</c:v>
@@ -8167,27 +8167,146 @@
       </p:sp>
       <p:sp>
         <p:nvSpPr>
-          <p:cNvPr id="13" name="TextBox 12"/>
-          <p:cNvSpPr txBox="1"/>
-          <p:nvPr/>
-        </p:nvSpPr>
-        <p:spPr>
-          <a:xfrm>
-            <a:off x="685800" y="5715000"/>
-            <a:ext cx="4572000" cy="274320"/>
-          </a:xfrm>
-          <a:prstGeom prst="rect">
-            <a:avLst/>
-          </a:prstGeom>
-          <a:noFill/>
-        </p:spPr>
-        <p:txBody>
-          <a:bodyPr wrap="square" lIns="36576" rIns="36576" tIns="36576" bIns="36576" anchor="t">
+          <p:cNvPr id="13" name="TextBox 12">
+            <a:extLst xmlns:a="http://schemas.openxmlformats.org/drawingml/2006/main">
+              <a:ext uri="{FF2B5EF4-FFF2-40B4-BE49-F238E27FC236}">
+                <a16:creationId xmlns:a16="http://schemas.microsoft.com/office/drawing/2014/main" id="{7D57065F-7002-484C-BA6D-24A676A93B75}"/>
+              </a:ext>
+            </a:extLst>
+          </p:cNvPr>
+          <p:cNvSpPr>
+            <a:spLocks xmlns:a="http://schemas.openxmlformats.org/drawingml/2006/main" noGrp="1"/>
+          </p:cNvSpPr>
+          <p:nvPr/>
+        </p:nvSpPr>
+        <p:spPr>
+          <a:xfrm xmlns:a="http://schemas.openxmlformats.org/drawingml/2006/main">
+            <a:off x="685800" y="5181600"/>
+            <a:ext cx="5953125" cy="285750"/>
+          </a:xfrm>
+          <a:prstGeom xmlns:a="http://schemas.openxmlformats.org/drawingml/2006/main" prst="rect">
+            <a:avLst/>
+          </a:prstGeom>
+          <a:noFill xmlns:a="http://schemas.openxmlformats.org/drawingml/2006/main"/>
+        </p:spPr>
+        <p:txBody>
+          <a:bodyPr xmlns:a="http://schemas.openxmlformats.org/drawingml/2006/main" wrap="none" lIns="36576" tIns="36576" rIns="36576" bIns="36576" anchor="t">
             <a:noAutofit/>
           </a:bodyPr>
-          <a:lstStyle/>
-          <a:p>
-            <a:pPr algn="l"/>
+          <a:lstStyle xmlns:a="http://schemas.openxmlformats.org/drawingml/2006/main">
+            <a:defPPr algn="l">
+              <a:defRPr sz="1200" b="1">
+                <a:solidFill>
+                  <a:srgbClr val="5A6573"/>
+                </a:solidFill>
+                <a:latin typeface="Aptos"/>
+                <a:ea typeface="Aptos"/>
+                <a:cs typeface="Aptos"/>
+              </a:defRPr>
+            </a:defPPr>
+            <a:lvl1pPr algn="l">
+              <a:defRPr sz="1200" b="1">
+                <a:solidFill>
+                  <a:srgbClr val="5A6573"/>
+                </a:solidFill>
+                <a:latin typeface="Aptos"/>
+                <a:ea typeface="Aptos"/>
+                <a:cs typeface="Aptos"/>
+              </a:defRPr>
+            </a:lvl1pPr>
+            <a:lvl2pPr algn="l">
+              <a:defRPr sz="1200" b="1">
+                <a:solidFill>
+                  <a:srgbClr val="5A6573"/>
+                </a:solidFill>
+                <a:latin typeface="Aptos"/>
+                <a:ea typeface="Aptos"/>
+                <a:cs typeface="Aptos"/>
+              </a:defRPr>
+            </a:lvl2pPr>
+            <a:lvl3pPr algn="l">
+              <a:defRPr sz="1200" b="1">
+                <a:solidFill>
+                  <a:srgbClr val="5A6573"/>
+                </a:solidFill>
+                <a:latin typeface="Aptos"/>
+                <a:ea typeface="Aptos"/>
+                <a:cs typeface="Aptos"/>
+              </a:defRPr>
+            </a:lvl3pPr>
+            <a:lvl4pPr algn="l">
+              <a:defRPr sz="1200" b="1">
+                <a:solidFill>
+                  <a:srgbClr val="5A6573"/>
+                </a:solidFill>
+                <a:latin typeface="Aptos"/>
+                <a:ea typeface="Aptos"/>
+                <a:cs typeface="Aptos"/>
+              </a:defRPr>
+            </a:lvl4pPr>
+            <a:lvl5pPr algn="l">
+              <a:defRPr sz="1200" b="1">
+                <a:solidFill>
+                  <a:srgbClr val="5A6573"/>
+                </a:solidFill>
+                <a:latin typeface="Aptos"/>
+                <a:ea typeface="Aptos"/>
+                <a:cs typeface="Aptos"/>
+              </a:defRPr>
+            </a:lvl5pPr>
+            <a:lvl6pPr algn="l">
+              <a:defRPr sz="1200" b="1">
+                <a:solidFill>
+                  <a:srgbClr val="5A6573"/>
+                </a:solidFill>
+                <a:latin typeface="Aptos"/>
+                <a:ea typeface="Aptos"/>
+                <a:cs typeface="Aptos"/>
+              </a:defRPr>
+            </a:lvl6pPr>
+            <a:lvl7pPr algn="l">
+              <a:defRPr sz="1200" b="1">
+                <a:solidFill>
+                  <a:srgbClr val="5A6573"/>
+                </a:solidFill>
+                <a:latin typeface="Aptos"/>
+                <a:ea typeface="Aptos"/>
+                <a:cs typeface="Aptos"/>
+              </a:defRPr>
+            </a:lvl7pPr>
+            <a:lvl8pPr algn="l">
+              <a:defRPr sz="1200" b="1">
+                <a:solidFill>
+                  <a:srgbClr val="5A6573"/>
+                </a:solidFill>
+                <a:latin typeface="Aptos"/>
+                <a:ea typeface="Aptos"/>
+                <a:cs typeface="Aptos"/>
+              </a:defRPr>
+            </a:lvl8pPr>
+            <a:lvl9pPr algn="l">
+              <a:defRPr sz="1200" b="1">
+                <a:solidFill>
+                  <a:srgbClr val="5A6573"/>
+                </a:solidFill>
+                <a:latin typeface="Aptos"/>
+                <a:ea typeface="Aptos"/>
+                <a:cs typeface="Aptos"/>
+              </a:defRPr>
+            </a:lvl9pPr>
+          </a:lstStyle>
+          <a:p xmlns:a="http://schemas.openxmlformats.org/drawingml/2006/main">
+            <a:pPr algn="l">
+              <a:buNone/>
+              <a:defRPr sz="1200" b="1">
+                <a:solidFill>
+                  <a:srgbClr val="5A6573"/>
+                </a:solidFill>
+                <a:latin typeface="Aptos"/>
+                <a:ea typeface="Aptos"/>
+                <a:cs typeface="Aptos"/>
+              </a:defRPr>
+            </a:pPr>
             <a:r>
               <a:rPr sz="1200" b="1" i="0">
                 <a:solidFill>
@@ -8197,44 +8316,244 @@
                 <a:ea typeface="Aptos"/>
                 <a:cs typeface="Aptos"/>
               </a:rPr>
-              <a:t>CE7490 Course Project</a:t>
-            </a:r>
-          </a:p>
-        </p:txBody>
-      </p:sp>
-      <p:sp>
-        <p:nvSpPr>
-          <p:cNvPr id="14" name="TextBox 13"/>
-          <p:cNvSpPr txBox="1"/>
-          <p:nvPr/>
-        </p:nvSpPr>
-        <p:spPr>
-          <a:xfrm>
-            <a:off x="685800" y="6035040"/>
-            <a:ext cx="4572000" cy="256032"/>
-          </a:xfrm>
-          <a:prstGeom prst="rect">
-            <a:avLst/>
-          </a:prstGeom>
-          <a:noFill/>
-        </p:spPr>
-        <p:txBody>
-          <a:bodyPr wrap="square" lIns="36576" rIns="36576" tIns="36576" bIns="36576" anchor="t">
+              <a:t>CE7490 Course Project - 26S1 Group 5</a:t>
+            </a:r>
+          </a:p>
+        </p:txBody>
+      </p:sp>
+      <p:sp>
+        <p:nvSpPr>
+          <p:cNvPr id="14" name="TextBox 13">
+            <a:extLst xmlns:a="http://schemas.openxmlformats.org/drawingml/2006/main">
+              <a:ext uri="{FF2B5EF4-FFF2-40B4-BE49-F238E27FC236}">
+                <a16:creationId xmlns:a16="http://schemas.microsoft.com/office/drawing/2014/main" id="{F8BB1398-E002-4C7A-AE64-6C88A0941092}"/>
+              </a:ext>
+            </a:extLst>
+          </p:cNvPr>
+          <p:cNvSpPr>
+            <a:spLocks xmlns:a="http://schemas.openxmlformats.org/drawingml/2006/main" noGrp="1"/>
+          </p:cNvSpPr>
+          <p:nvPr/>
+        </p:nvSpPr>
+        <p:spPr>
+          <a:xfrm xmlns:a="http://schemas.openxmlformats.org/drawingml/2006/main">
+            <a:off x="685800" y="5524500"/>
+            <a:ext cx="5953125" cy="857250"/>
+          </a:xfrm>
+          <a:prstGeom xmlns:a="http://schemas.openxmlformats.org/drawingml/2006/main" prst="rect">
+            <a:avLst/>
+          </a:prstGeom>
+          <a:noFill xmlns:a="http://schemas.openxmlformats.org/drawingml/2006/main"/>
+        </p:spPr>
+        <p:txBody>
+          <a:bodyPr xmlns:a="http://schemas.openxmlformats.org/drawingml/2006/main" wrap="none" lIns="36576" tIns="36576" rIns="36576" bIns="36576" anchor="t">
             <a:noAutofit/>
           </a:bodyPr>
-          <a:lstStyle/>
-          <a:p>
-            <a:pPr algn="l"/>
-            <a:r>
-              <a:rPr sz="1100" b="0" i="0">
+          <a:lstStyle xmlns:a="http://schemas.openxmlformats.org/drawingml/2006/main">
+            <a:defPPr algn="l">
+              <a:defRPr sz="1150" b="0">
                 <a:solidFill>
                   <a:srgbClr val="5A6573"/>
                 </a:solidFill>
                 <a:latin typeface="Aptos"/>
                 <a:ea typeface="Aptos"/>
                 <a:cs typeface="Aptos"/>
+              </a:defRPr>
+            </a:defPPr>
+            <a:lvl1pPr algn="l">
+              <a:defRPr sz="1150" b="0">
+                <a:solidFill>
+                  <a:srgbClr val="5A6573"/>
+                </a:solidFill>
+                <a:latin typeface="Aptos"/>
+                <a:ea typeface="Aptos"/>
+                <a:cs typeface="Aptos"/>
+              </a:defRPr>
+            </a:lvl1pPr>
+            <a:lvl2pPr algn="l">
+              <a:defRPr sz="1150" b="0">
+                <a:solidFill>
+                  <a:srgbClr val="5A6573"/>
+                </a:solidFill>
+                <a:latin typeface="Aptos"/>
+                <a:ea typeface="Aptos"/>
+                <a:cs typeface="Aptos"/>
+              </a:defRPr>
+            </a:lvl2pPr>
+            <a:lvl3pPr algn="l">
+              <a:defRPr sz="1150" b="0">
+                <a:solidFill>
+                  <a:srgbClr val="5A6573"/>
+                </a:solidFill>
+                <a:latin typeface="Aptos"/>
+                <a:ea typeface="Aptos"/>
+                <a:cs typeface="Aptos"/>
+              </a:defRPr>
+            </a:lvl3pPr>
+            <a:lvl4pPr algn="l">
+              <a:defRPr sz="1150" b="0">
+                <a:solidFill>
+                  <a:srgbClr val="5A6573"/>
+                </a:solidFill>
+                <a:latin typeface="Aptos"/>
+                <a:ea typeface="Aptos"/>
+                <a:cs typeface="Aptos"/>
+              </a:defRPr>
+            </a:lvl4pPr>
+            <a:lvl5pPr algn="l">
+              <a:defRPr sz="1150" b="0">
+                <a:solidFill>
+                  <a:srgbClr val="5A6573"/>
+                </a:solidFill>
+                <a:latin typeface="Aptos"/>
+                <a:ea typeface="Aptos"/>
+                <a:cs typeface="Aptos"/>
+              </a:defRPr>
+            </a:lvl5pPr>
+            <a:lvl6pPr algn="l">
+              <a:defRPr sz="1150" b="0">
+                <a:solidFill>
+                  <a:srgbClr val="5A6573"/>
+                </a:solidFill>
+                <a:latin typeface="Aptos"/>
+                <a:ea typeface="Aptos"/>
+                <a:cs typeface="Aptos"/>
+              </a:defRPr>
+            </a:lvl6pPr>
+            <a:lvl7pPr algn="l">
+              <a:defRPr sz="1150" b="0">
+                <a:solidFill>
+                  <a:srgbClr val="5A6573"/>
+                </a:solidFill>
+                <a:latin typeface="Aptos"/>
+                <a:ea typeface="Aptos"/>
+                <a:cs typeface="Aptos"/>
+              </a:defRPr>
+            </a:lvl7pPr>
+            <a:lvl8pPr algn="l">
+              <a:defRPr sz="1150" b="0">
+                <a:solidFill>
+                  <a:srgbClr val="5A6573"/>
+                </a:solidFill>
+                <a:latin typeface="Aptos"/>
+                <a:ea typeface="Aptos"/>
+                <a:cs typeface="Aptos"/>
+              </a:defRPr>
+            </a:lvl8pPr>
+            <a:lvl9pPr algn="l">
+              <a:defRPr sz="1150" b="0">
+                <a:solidFill>
+                  <a:srgbClr val="5A6573"/>
+                </a:solidFill>
+                <a:latin typeface="Aptos"/>
+                <a:ea typeface="Aptos"/>
+                <a:cs typeface="Aptos"/>
+              </a:defRPr>
+            </a:lvl9pPr>
+          </a:lstStyle>
+          <a:p xmlns:a="http://schemas.openxmlformats.org/drawingml/2006/main">
+            <a:pPr algn="l">
+              <a:buNone/>
+              <a:defRPr sz="1150" b="0">
+                <a:solidFill>
+                  <a:srgbClr val="5A6573"/>
+                </a:solidFill>
+                <a:latin typeface="Aptos"/>
+                <a:ea typeface="Aptos"/>
+                <a:cs typeface="Aptos"/>
+              </a:defRPr>
+            </a:pPr>
+            <a:r>
+              <a:rPr sz="1150" b="1" i="0">
+                <a:solidFill>
+                  <a:srgbClr val="5A6573"/>
+                </a:solidFill>
+                <a:latin typeface="Aptos"/>
+                <a:ea typeface="Aptos"/>
+                <a:cs typeface="Aptos"/>
               </a:rPr>
-              <a:t>Revised 29 October 2026</a:t>
+              <a:t>Zhang Qi</a:t>
+            </a:r>
+            <a:r>
+              <a:rPr sz="1150" b="0" i="0">
+                <a:solidFill>
+                  <a:srgbClr val="5A6573"/>
+                </a:solidFill>
+                <a:latin typeface="Aptos"/>
+                <a:ea typeface="Aptos"/>
+                <a:cs typeface="Aptos"/>
+              </a:rPr>
+              <a:t> (G2510784F)  qi015@e.ntu.edu.sg</a:t>
+            </a:r>
+          </a:p>
+          <a:p xmlns:a="http://schemas.openxmlformats.org/drawingml/2006/main">
+            <a:pPr algn="l">
+              <a:buNone/>
+              <a:defRPr sz="1150" b="0">
+                <a:solidFill>
+                  <a:srgbClr val="5A6573"/>
+                </a:solidFill>
+                <a:latin typeface="Aptos"/>
+                <a:ea typeface="Aptos"/>
+                <a:cs typeface="Aptos"/>
+              </a:defRPr>
+            </a:pPr>
+            <a:r>
+              <a:rPr sz="1150" b="1" i="0">
+                <a:solidFill>
+                  <a:srgbClr val="5A6573"/>
+                </a:solidFill>
+                <a:latin typeface="Aptos"/>
+                <a:ea typeface="Aptos"/>
+                <a:cs typeface="Aptos"/>
+              </a:rPr>
+              <a:t>Zhang Saining</a:t>
+            </a:r>
+            <a:r>
+              <a:rPr sz="1150" b="0" i="0">
+                <a:solidFill>
+                  <a:srgbClr val="5A6573"/>
+                </a:solidFill>
+                <a:latin typeface="Aptos"/>
+                <a:ea typeface="Aptos"/>
+                <a:cs typeface="Aptos"/>
+              </a:rPr>
+              <a:t> (G2511061H)  saining002@e.ntu.edu.sg</a:t>
+            </a:r>
+          </a:p>
+          <a:p xmlns:a="http://schemas.openxmlformats.org/drawingml/2006/main">
+            <a:pPr algn="l">
+              <a:buNone/>
+              <a:defRPr sz="1150" b="0">
+                <a:solidFill>
+                  <a:srgbClr val="5A6573"/>
+                </a:solidFill>
+                <a:latin typeface="Aptos"/>
+                <a:ea typeface="Aptos"/>
+                <a:cs typeface="Aptos"/>
+              </a:defRPr>
+            </a:pPr>
+            <a:r>
+              <a:rPr sz="1150" b="1" i="0">
+                <a:solidFill>
+                  <a:srgbClr val="5A6573"/>
+                </a:solidFill>
+                <a:latin typeface="Aptos"/>
+                <a:ea typeface="Aptos"/>
+                <a:cs typeface="Aptos"/>
+              </a:rPr>
+              <a:t>Zheng Yitao</a:t>
+            </a:r>
+            <a:r>
+              <a:rPr sz="1150" b="0" i="0">
+                <a:solidFill>
+                  <a:srgbClr val="5A6573"/>
+                </a:solidFill>
+                <a:latin typeface="Aptos"/>
+                <a:ea typeface="Aptos"/>
+                <a:cs typeface="Aptos"/>
+              </a:rPr>
+              <a:t> (G2608664B)  YZHENG056@e.ntu.edu.sg</a:t>
             </a:r>
           </a:p>
         </p:txBody>

</xml_diff>